<commit_message>
Topic A exam practice: L04 workshops; short titles on title slides
Co-Authored-By: Claude Opus 5.5 <noreply@anthropic.com>
Claude-Session: https://claude.ai/code/session_01QWUKnGV7MRCnE8883pixoX
</commit_message>
<xml_diff>
--- a/Topic_A/Exam_Practice/AT-A-L02_Speaking_Workshop_Calendar_Dates_and_the_School_Week.pptx
+++ b/Topic_A/Exam_Practice/AT-A-L02_Speaking_Workshop_Calendar_Dates_and_the_School_Week.pptx
@@ -3326,7 +3326,7 @@
                 <a:latin typeface="Cambria" pitchFamily="34" charset="0"/>
                 <a:cs typeface="Amiri" pitchFamily="2" charset="-78"/>
               </a:rPr>
-              <a:t>Speaking Workshop — Calendar, Dates and the School Week</a:t>
+              <a:t>Speaking Workshop — Calendar and the School Week</a:t>
             </a:r>
             <a:endParaRPr lang="en-US" sz="2650" dirty="0"/>
           </a:p>
@@ -3357,16 +3357,16 @@
               <a:buNone/>
             </a:pPr>
             <a:r>
-              <a:rPr lang="ar-SA" altLang="en-US" sz="3300" b="1" dirty="0">
+              <a:rPr lang="ar-SA" altLang="en-US" sz="3600" b="1" dirty="0">
                 <a:solidFill>
                   <a:srgbClr val="D4AF37"/>
                 </a:solidFill>
                 <a:latin typeface="Amiri" pitchFamily="2" charset="-78"/>
                 <a:cs typeface="Amiri" pitchFamily="2" charset="-78"/>
               </a:rPr>
-              <a:t>وَرْشَةُ التَّحَدُّثِ — التَّقْوِيمُ وَالتَّوَارِيخُ وَالأُسْبُوعُ الدِّرَاسِيُّ</a:t>
-            </a:r>
-            <a:endParaRPr lang="ar-SA" sz="3300" dirty="0"/>
+              <a:t>وَرْشَةُ التَّحَدُّثِ — التَّقْوِيمُ وَالأُسْبُوعُ الدِّرَاسِيُّ</a:t>
+            </a:r>
+            <a:endParaRPr lang="ar-SA" sz="3600" dirty="0"/>
           </a:p>
         </p:txBody>
       </p:sp>

</xml_diff>